<commit_message>
Added new boxplot in result
</commit_message>
<xml_diff>
--- a/source/Samples/NeocortexApiSamplePerformance/Documentation/ML-24-25-05 Implement Performance Measurement Experiment_PerfEX Presnetation.pptx
+++ b/source/Samples/NeocortexApiSamplePerformance/Documentation/ML-24-25-05 Implement Performance Measurement Experiment_PerfEX Presnetation.pptx
@@ -213,7 +213,7 @@
           <a:p>
             <a:fld id="{A8510A8F-EF3D-4B94-B8DD-8A559847BC33}" type="datetimeFigureOut">
               <a:rPr lang="en-GB" smtClean="0"/>
-              <a:t>27/03/2025</a:t>
+              <a:t>06/04/2025</a:t>
             </a:fld>
             <a:endParaRPr lang="en-GB"/>
           </a:p>
@@ -1725,7 +1725,7 @@
             <a:pPr algn="l"/>
             <a:fld id="{9DAE42CC-54F2-4371-8B7D-45825AA60A72}" type="datetime1">
               <a:rPr lang="en-US" smtClean="0"/>
-              <a:t>3/27/2025</a:t>
+              <a:t>4/6/2025</a:t>
             </a:fld>
             <a:endParaRPr lang="en-US" dirty="0"/>
           </a:p>
@@ -1929,7 +1929,7 @@
           <a:p>
             <a:fld id="{34DAC050-3FD3-435C-A76E-04B57AA0571A}" type="datetime1">
               <a:rPr lang="en-US" smtClean="0"/>
-              <a:t>3/27/2025</a:t>
+              <a:t>4/6/2025</a:t>
             </a:fld>
             <a:endParaRPr lang="en-US" dirty="0"/>
           </a:p>
@@ -2143,7 +2143,7 @@
           <a:p>
             <a:fld id="{A4B74034-D052-47F7-B82B-8FE5E38143D8}" type="datetime1">
               <a:rPr lang="en-US" smtClean="0"/>
-              <a:t>3/27/2025</a:t>
+              <a:t>4/6/2025</a:t>
             </a:fld>
             <a:endParaRPr lang="en-US"/>
           </a:p>
@@ -2347,7 +2347,7 @@
           <a:p>
             <a:fld id="{2657DE8A-5CB4-44EE-9744-F301D6131B93}" type="datetime1">
               <a:rPr lang="en-US" smtClean="0"/>
-              <a:t>3/27/2025</a:t>
+              <a:t>4/6/2025</a:t>
             </a:fld>
             <a:endParaRPr lang="en-US" dirty="0"/>
           </a:p>
@@ -2627,7 +2627,7 @@
           <a:p>
             <a:fld id="{5B2D2200-03CD-41DD-B0DF-8792C811816E}" type="datetime1">
               <a:rPr lang="en-US" smtClean="0"/>
-              <a:t>3/27/2025</a:t>
+              <a:t>4/6/2025</a:t>
             </a:fld>
             <a:endParaRPr lang="en-US" dirty="0"/>
           </a:p>
@@ -2899,7 +2899,7 @@
           <a:p>
             <a:fld id="{ABCAD776-474D-4509-8ABD-B76E59C4EA47}" type="datetime1">
               <a:rPr lang="en-US" smtClean="0"/>
-              <a:t>3/27/2025</a:t>
+              <a:t>4/6/2025</a:t>
             </a:fld>
             <a:endParaRPr lang="en-US" dirty="0"/>
           </a:p>
@@ -3318,7 +3318,7 @@
           <a:p>
             <a:fld id="{03D317CA-E6EF-4799-A15F-9FA1B62F5FAD}" type="datetime1">
               <a:rPr lang="en-US" smtClean="0"/>
-              <a:t>3/27/2025</a:t>
+              <a:t>4/6/2025</a:t>
             </a:fld>
             <a:endParaRPr lang="en-US" dirty="0"/>
           </a:p>
@@ -3464,7 +3464,7 @@
           <a:p>
             <a:fld id="{79D49B58-E195-4333-BEB2-A22152AB439D}" type="datetime1">
               <a:rPr lang="en-US" smtClean="0"/>
-              <a:t>3/27/2025</a:t>
+              <a:t>4/6/2025</a:t>
             </a:fld>
             <a:endParaRPr lang="en-US" dirty="0"/>
           </a:p>
@@ -3581,7 +3581,7 @@
           <a:p>
             <a:fld id="{F610B6D6-6985-4098-BA4F-4F5BB359C165}" type="datetime1">
               <a:rPr lang="en-US" smtClean="0"/>
-              <a:t>3/27/2025</a:t>
+              <a:t>4/6/2025</a:t>
             </a:fld>
             <a:endParaRPr lang="en-US" dirty="0"/>
           </a:p>
@@ -3899,7 +3899,7 @@
           <a:p>
             <a:fld id="{17B67C40-D887-419C-BF74-30657AE68D78}" type="datetime1">
               <a:rPr lang="en-US" smtClean="0"/>
-              <a:t>3/27/2025</a:t>
+              <a:t>4/6/2025</a:t>
             </a:fld>
             <a:endParaRPr lang="en-US" dirty="0"/>
           </a:p>
@@ -4192,7 +4192,7 @@
           <a:p>
             <a:fld id="{F07DC399-5085-4C53-864E-53AF786663A6}" type="datetime1">
               <a:rPr lang="en-US" smtClean="0"/>
-              <a:t>3/27/2025</a:t>
+              <a:t>4/6/2025</a:t>
             </a:fld>
             <a:endParaRPr lang="en-US" dirty="0"/>
           </a:p>
@@ -4439,7 +4439,7 @@
           <a:p>
             <a:fld id="{EFC3E194-E3B4-4030-879B-05C9910A0D64}" type="datetime1">
               <a:rPr lang="en-US" smtClean="0"/>
-              <a:t>3/27/2025</a:t>
+              <a:t>4/6/2025</a:t>
             </a:fld>
             <a:endParaRPr lang="en-US" dirty="0"/>
           </a:p>
@@ -6537,14 +6537,14 @@
           <a:lstStyle/>
           <a:p>
             <a:r>
-              <a:rPr lang="en-IN" sz="3600" dirty="0">
+              <a:rPr lang="en-IN" sz="3600">
                 <a:latin typeface="Times New Roman" panose="02020603050405020304" pitchFamily="18" charset="0"/>
                 <a:cs typeface="Times New Roman" panose="02020603050405020304" pitchFamily="18" charset="0"/>
               </a:rPr>
               <a:t>R</a:t>
             </a:r>
             <a:r>
-              <a:rPr lang="en-PK" sz="3600" dirty="0">
+              <a:rPr lang="en-PK" sz="3600">
                 <a:latin typeface="Times New Roman" panose="02020603050405020304" pitchFamily="18" charset="0"/>
                 <a:cs typeface="Times New Roman" panose="02020603050405020304" pitchFamily="18" charset="0"/>
               </a:rPr>
@@ -6719,51 +6719,19 @@
           <a:lstStyle/>
           <a:p>
             <a:r>
-              <a:rPr lang="en-GB" sz="1800" dirty="0">
+              <a:rPr lang="en-GB" sz="1800">
                 <a:latin typeface="Times New Roman" panose="02020603050405020304" pitchFamily="18" charset="0"/>
                 <a:cs typeface="Times New Roman" panose="02020603050405020304" pitchFamily="18" charset="0"/>
               </a:rPr>
               <a:t>Learning time vs .NET Version</a:t>
             </a:r>
-          </a:p>
-        </p:txBody>
-      </p:sp>
-      <p:pic>
-        <p:nvPicPr>
-          <p:cNvPr id="11" name="Picture 10" descr="A graph of a graph showing a number of different sizes&#10;&#10;AI-generated content may be incorrect.">
-            <a:extLst>
-              <a:ext uri="{FF2B5EF4-FFF2-40B4-BE49-F238E27FC236}">
-                <a16:creationId xmlns:a16="http://schemas.microsoft.com/office/drawing/2014/main" id="{F507C856-6ADB-6161-86B3-E12FB25022A5}"/>
-              </a:ext>
-            </a:extLst>
-          </p:cNvPr>
-          <p:cNvPicPr>
-            <a:picLocks noChangeAspect="1"/>
-          </p:cNvPicPr>
-          <p:nvPr/>
-        </p:nvPicPr>
-        <p:blipFill>
-          <a:blip r:embed="rId3">
-            <a:extLst>
-              <a:ext uri="{28A0092B-C50C-407E-A947-70E740481C1C}">
-                <a14:useLocalDpi xmlns:a14="http://schemas.microsoft.com/office/drawing/2010/main" val="0"/>
-              </a:ext>
-            </a:extLst>
-          </a:blip>
-          <a:stretch>
-            <a:fillRect/>
-          </a:stretch>
-        </p:blipFill>
-        <p:spPr>
-          <a:xfrm>
-            <a:off x="5911532" y="2731915"/>
-            <a:ext cx="5150277" cy="3218924"/>
-          </a:xfrm>
-          <a:prstGeom prst="rect">
-            <a:avLst/>
-          </a:prstGeom>
-        </p:spPr>
-      </p:pic>
+            <a:endParaRPr lang="en-GB" sz="1800" dirty="0">
+              <a:latin typeface="Times New Roman" panose="02020603050405020304" pitchFamily="18" charset="0"/>
+              <a:cs typeface="Times New Roman" panose="02020603050405020304" pitchFamily="18" charset="0"/>
+            </a:endParaRPr>
+          </a:p>
+        </p:txBody>
+      </p:sp>
       <p:sp>
         <p:nvSpPr>
           <p:cNvPr id="29" name="Rectangle 28">
@@ -6861,13 +6829,49 @@
               </a:spcAft>
             </a:pPr>
             <a:r>
-              <a:rPr lang="en-GB" dirty="0"/>
+              <a:rPr lang="en-GB"/>
               <a:t>Frankfurt University of Applied Sciences 2024/25</a:t>
             </a:r>
             <a:endParaRPr lang="en-US" dirty="0"/>
           </a:p>
         </p:txBody>
       </p:sp>
+      <p:pic>
+        <p:nvPicPr>
+          <p:cNvPr id="8" name="Picture 7">
+            <a:extLst>
+              <a:ext uri="{FF2B5EF4-FFF2-40B4-BE49-F238E27FC236}">
+                <a16:creationId xmlns:a16="http://schemas.microsoft.com/office/drawing/2014/main" id="{CF1BA563-4E9E-6AE0-6AA3-9464BE822750}"/>
+              </a:ext>
+            </a:extLst>
+          </p:cNvPr>
+          <p:cNvPicPr>
+            <a:picLocks noChangeAspect="1"/>
+          </p:cNvPicPr>
+          <p:nvPr/>
+        </p:nvPicPr>
+        <p:blipFill>
+          <a:blip r:embed="rId3">
+            <a:extLst>
+              <a:ext uri="{28A0092B-C50C-407E-A947-70E740481C1C}">
+                <a14:useLocalDpi xmlns:a14="http://schemas.microsoft.com/office/drawing/2010/main" val="0"/>
+              </a:ext>
+            </a:extLst>
+          </a:blip>
+          <a:stretch>
+            <a:fillRect/>
+          </a:stretch>
+        </p:blipFill>
+        <p:spPr>
+          <a:xfrm>
+            <a:off x="6095999" y="3152559"/>
+            <a:ext cx="3977986" cy="2486241"/>
+          </a:xfrm>
+          <a:prstGeom prst="rect">
+            <a:avLst/>
+          </a:prstGeom>
+        </p:spPr>
+      </p:pic>
     </p:spTree>
     <p:extLst>
       <p:ext uri="{BB962C8B-B14F-4D97-AF65-F5344CB8AC3E}">
@@ -7200,42 +7204,6 @@
           </a:p>
         </p:txBody>
       </p:sp>
-      <p:pic>
-        <p:nvPicPr>
-          <p:cNvPr id="9" name="Picture 8" descr="A graph with green and white lines&#10;&#10;AI-generated content may be incorrect.">
-            <a:extLst>
-              <a:ext uri="{FF2B5EF4-FFF2-40B4-BE49-F238E27FC236}">
-                <a16:creationId xmlns:a16="http://schemas.microsoft.com/office/drawing/2014/main" id="{7BDC17F3-A558-EE4D-FDF2-416C16800C30}"/>
-              </a:ext>
-            </a:extLst>
-          </p:cNvPr>
-          <p:cNvPicPr>
-            <a:picLocks noChangeAspect="1"/>
-          </p:cNvPicPr>
-          <p:nvPr/>
-        </p:nvPicPr>
-        <p:blipFill>
-          <a:blip r:embed="rId3">
-            <a:extLst>
-              <a:ext uri="{28A0092B-C50C-407E-A947-70E740481C1C}">
-                <a14:useLocalDpi xmlns:a14="http://schemas.microsoft.com/office/drawing/2010/main" val="0"/>
-              </a:ext>
-            </a:extLst>
-          </a:blip>
-          <a:stretch>
-            <a:fillRect/>
-          </a:stretch>
-        </p:blipFill>
-        <p:spPr>
-          <a:xfrm>
-            <a:off x="5911532" y="2731915"/>
-            <a:ext cx="5150277" cy="3218924"/>
-          </a:xfrm>
-          <a:prstGeom prst="rect">
-            <a:avLst/>
-          </a:prstGeom>
-        </p:spPr>
-      </p:pic>
       <p:sp>
         <p:nvSpPr>
           <p:cNvPr id="20" name="Rectangle 19">
@@ -7340,6 +7308,78 @@
           </a:p>
         </p:txBody>
       </p:sp>
+      <p:pic>
+        <p:nvPicPr>
+          <p:cNvPr id="5" name="Picture 4" descr="A graph with a green line&#10;&#10;AI-generated content may be incorrect.">
+            <a:extLst>
+              <a:ext uri="{FF2B5EF4-FFF2-40B4-BE49-F238E27FC236}">
+                <a16:creationId xmlns:a16="http://schemas.microsoft.com/office/drawing/2014/main" id="{629719E0-D0A2-D5B1-3EF7-E54B021B4858}"/>
+              </a:ext>
+            </a:extLst>
+          </p:cNvPr>
+          <p:cNvPicPr>
+            <a:picLocks noChangeAspect="1"/>
+          </p:cNvPicPr>
+          <p:nvPr/>
+        </p:nvPicPr>
+        <p:blipFill>
+          <a:blip r:embed="rId3">
+            <a:extLst>
+              <a:ext uri="{28A0092B-C50C-407E-A947-70E740481C1C}">
+                <a14:useLocalDpi xmlns:a14="http://schemas.microsoft.com/office/drawing/2010/main" val="0"/>
+              </a:ext>
+            </a:extLst>
+          </a:blip>
+          <a:stretch>
+            <a:fillRect/>
+          </a:stretch>
+        </p:blipFill>
+        <p:spPr>
+          <a:xfrm>
+            <a:off x="5691681" y="2907009"/>
+            <a:ext cx="5128776" cy="3205485"/>
+          </a:xfrm>
+          <a:prstGeom prst="rect">
+            <a:avLst/>
+          </a:prstGeom>
+        </p:spPr>
+      </p:pic>
+      <p:pic>
+        <p:nvPicPr>
+          <p:cNvPr id="6" name="Picture 5" descr="A graph with a green line&#10;&#10;AI-generated content may be incorrect.">
+            <a:extLst>
+              <a:ext uri="{FF2B5EF4-FFF2-40B4-BE49-F238E27FC236}">
+                <a16:creationId xmlns:a16="http://schemas.microsoft.com/office/drawing/2014/main" id="{429EA137-4BAD-6092-EF10-074EE3489892}"/>
+              </a:ext>
+            </a:extLst>
+          </p:cNvPr>
+          <p:cNvPicPr>
+            <a:picLocks noChangeAspect="1"/>
+          </p:cNvPicPr>
+          <p:nvPr/>
+        </p:nvPicPr>
+        <p:blipFill>
+          <a:blip r:embed="rId3">
+            <a:extLst>
+              <a:ext uri="{28A0092B-C50C-407E-A947-70E740481C1C}">
+                <a14:useLocalDpi xmlns:a14="http://schemas.microsoft.com/office/drawing/2010/main" val="0"/>
+              </a:ext>
+            </a:extLst>
+          </a:blip>
+          <a:stretch>
+            <a:fillRect/>
+          </a:stretch>
+        </p:blipFill>
+        <p:spPr>
+          <a:xfrm>
+            <a:off x="5844081" y="3059409"/>
+            <a:ext cx="5128776" cy="3205485"/>
+          </a:xfrm>
+          <a:prstGeom prst="rect">
+            <a:avLst/>
+          </a:prstGeom>
+        </p:spPr>
+      </p:pic>
     </p:spTree>
     <p:extLst>
       <p:ext uri="{BB962C8B-B14F-4D97-AF65-F5344CB8AC3E}">
@@ -7672,42 +7712,6 @@
           </a:p>
         </p:txBody>
       </p:sp>
-      <p:pic>
-        <p:nvPicPr>
-          <p:cNvPr id="5" name="Picture 4" descr="A graph of a graph&#10;&#10;AI-generated content may be incorrect.">
-            <a:extLst>
-              <a:ext uri="{FF2B5EF4-FFF2-40B4-BE49-F238E27FC236}">
-                <a16:creationId xmlns:a16="http://schemas.microsoft.com/office/drawing/2014/main" id="{363E651E-FAE5-F484-5453-14792FD884FF}"/>
-              </a:ext>
-            </a:extLst>
-          </p:cNvPr>
-          <p:cNvPicPr>
-            <a:picLocks noChangeAspect="1"/>
-          </p:cNvPicPr>
-          <p:nvPr/>
-        </p:nvPicPr>
-        <p:blipFill>
-          <a:blip r:embed="rId3">
-            <a:extLst>
-              <a:ext uri="{28A0092B-C50C-407E-A947-70E740481C1C}">
-                <a14:useLocalDpi xmlns:a14="http://schemas.microsoft.com/office/drawing/2010/main" val="0"/>
-              </a:ext>
-            </a:extLst>
-          </a:blip>
-          <a:stretch>
-            <a:fillRect/>
-          </a:stretch>
-        </p:blipFill>
-        <p:spPr>
-          <a:xfrm>
-            <a:off x="5911532" y="2731915"/>
-            <a:ext cx="5150277" cy="3218924"/>
-          </a:xfrm>
-          <a:prstGeom prst="rect">
-            <a:avLst/>
-          </a:prstGeom>
-        </p:spPr>
-      </p:pic>
       <p:sp>
         <p:nvSpPr>
           <p:cNvPr id="18" name="Rectangle 17">
@@ -7812,6 +7816,42 @@
           </a:p>
         </p:txBody>
       </p:sp>
+      <p:pic>
+        <p:nvPicPr>
+          <p:cNvPr id="6" name="Picture 5" descr="A graph of a graph showing a number of different sizes and colors&#10;&#10;AI-generated content may be incorrect.">
+            <a:extLst>
+              <a:ext uri="{FF2B5EF4-FFF2-40B4-BE49-F238E27FC236}">
+                <a16:creationId xmlns:a16="http://schemas.microsoft.com/office/drawing/2014/main" id="{4DDDCECF-15FA-3AFB-1249-E8A48C6BD330}"/>
+              </a:ext>
+            </a:extLst>
+          </p:cNvPr>
+          <p:cNvPicPr>
+            <a:picLocks noChangeAspect="1"/>
+          </p:cNvPicPr>
+          <p:nvPr/>
+        </p:nvPicPr>
+        <p:blipFill>
+          <a:blip r:embed="rId3">
+            <a:extLst>
+              <a:ext uri="{28A0092B-C50C-407E-A947-70E740481C1C}">
+                <a14:useLocalDpi xmlns:a14="http://schemas.microsoft.com/office/drawing/2010/main" val="0"/>
+              </a:ext>
+            </a:extLst>
+          </a:blip>
+          <a:stretch>
+            <a:fillRect/>
+          </a:stretch>
+        </p:blipFill>
+        <p:spPr>
+          <a:xfrm>
+            <a:off x="5724548" y="2693691"/>
+            <a:ext cx="5258824" cy="3286765"/>
+          </a:xfrm>
+          <a:prstGeom prst="rect">
+            <a:avLst/>
+          </a:prstGeom>
+        </p:spPr>
+      </p:pic>
     </p:spTree>
     <p:extLst>
       <p:ext uri="{BB962C8B-B14F-4D97-AF65-F5344CB8AC3E}">

</xml_diff>